<commit_message>
Add initial outline documents for personal and presentation planning
- Created a new Word document for personal outline.
- Created a new PowerPoint presentation outline.
</commit_message>
<xml_diff>
--- a/presentation_outline.pptx
+++ b/presentation_outline.pptx
@@ -14,6 +14,7 @@
     <p:sldId id="262" r:id="rId13"/>
     <p:sldId id="263" r:id="rId14"/>
     <p:sldId id="264" r:id="rId15"/>
+    <p:sldId id="265" r:id="rId16"/>
   </p:sldIdLst>
   <p:sldSz cx="12191695" cy="6858000" type="screen4x3"/>
   <p:notesSz cx="6858000" cy="9144000"/>
@@ -3134,7 +3135,7 @@
           <a:lstStyle/>
           <a:p>
             <a:r>
-              <a:t>Monthly &amp; Weekly Analysis with Lagged Predictors</a:t>
+              <a:t>Volatility as the Transmission Channel</a:t>
             </a:r>
           </a:p>
           <a:p/>
@@ -3148,6 +3149,63 @@
               <a:t>[Your Name(s)]</a:t>
             </a:r>
           </a:p>
+        </p:txBody>
+      </p:sp>
+    </p:spTree>
+  </p:cSld>
+  <p:clrMapOvr>
+    <a:masterClrMapping/>
+  </p:clrMapOvr>
+</p:sld>
+</file>
+
+<file path=ppt/slides/slide10.xml><?xml version="1.0" encoding="utf-8"?>
+<p:sld xmlns:a="http://schemas.openxmlformats.org/drawingml/2006/main" xmlns:p="http://schemas.openxmlformats.org/presentationml/2006/main" xmlns:r="http://schemas.openxmlformats.org/officeDocument/2006/relationships">
+  <p:cSld>
+    <p:spTree>
+      <p:nvGrpSpPr>
+        <p:cNvPr id="1" name=""/>
+        <p:cNvGrpSpPr/>
+        <p:nvPr/>
+      </p:nvGrpSpPr>
+      <p:grpSpPr/>
+      <p:sp>
+        <p:nvSpPr>
+          <p:cNvPr id="2" name="Title 1"/>
+          <p:cNvSpPr>
+            <a:spLocks noGrp="1"/>
+          </p:cNvSpPr>
+          <p:nvPr>
+            <p:ph type="ctrTitle"/>
+          </p:nvPr>
+        </p:nvSpPr>
+        <p:spPr/>
+        <p:txBody>
+          <a:bodyPr/>
+          <a:lstStyle/>
+          <a:p>
+            <a:r>
+              <a:rPr sz="3600"/>
+              <a:t>Questions?</a:t>
+            </a:r>
+          </a:p>
+        </p:txBody>
+      </p:sp>
+      <p:sp>
+        <p:nvSpPr>
+          <p:cNvPr id="3" name="Subtitle 2"/>
+          <p:cNvSpPr>
+            <a:spLocks noGrp="1"/>
+          </p:cNvSpPr>
+          <p:nvPr>
+            <p:ph type="subTitle" idx="1"/>
+          </p:nvPr>
+        </p:nvSpPr>
+        <p:spPr/>
+        <p:txBody>
+          <a:bodyPr/>
+          <a:lstStyle/>
+          <a:p/>
         </p:txBody>
       </p:sp>
     </p:spTree>
@@ -3216,18 +3274,29 @@
               <a:defRPr sz="1800"/>
             </a:pPr>
             <a:r>
-              <a:t>Can lagged macro/financial variables predict WTI % changes?</a:t>
-            </a:r>
-          </a:p>
-          <a:p>
-            <a:pPr>
-              <a:spcAft>
-                <a:spcPts val="400"/>
-              </a:spcAft>
-              <a:defRPr sz="1800"/>
-            </a:pPr>
-            <a:r>
-              <a:t>Using X(t-1) to predict WTI(t) — a true forecasting model</a:t>
+              <a:t>Theory: Geopolitical threats + macro uncertainty → VOLATILITY → price changes</a:t>
+            </a:r>
+          </a:p>
+          <a:p>
+            <a:pPr>
+              <a:spcAft>
+                <a:spcPts val="400"/>
+              </a:spcAft>
+              <a:defRPr sz="1800"/>
+            </a:pPr>
+            <a:r>
+              <a:t>   High vol = prices spike (supply risk premia)</a:t>
+            </a:r>
+          </a:p>
+          <a:p>
+            <a:pPr>
+              <a:spcAft>
+                <a:spcPts val="400"/>
+              </a:spcAft>
+              <a:defRPr sz="1800"/>
+            </a:pPr>
+            <a:r>
+              <a:t>   Low vol = prices drift down (stable expectations)</a:t>
             </a:r>
           </a:p>
           <a:p>
@@ -3265,59 +3334,48 @@
               <a:defRPr sz="1800"/>
             </a:pPr>
             <a:r>
-              <a:t>Predictors in 3 categories:</a:t>
-            </a:r>
-          </a:p>
-          <a:p>
-            <a:pPr>
-              <a:spcAft>
-                <a:spcPts val="400"/>
-              </a:spcAft>
-              <a:defRPr sz="1800"/>
-            </a:pPr>
-            <a:r>
-              <a:t>   Energy: heating oil, nat gas, crude stocks, SPR, refinery util</a:t>
-            </a:r>
-          </a:p>
-          <a:p>
-            <a:pPr>
-              <a:spcAft>
-                <a:spcPts val="400"/>
-              </a:spcAft>
-              <a:defRPr sz="1800"/>
-            </a:pPr>
-            <a:r>
-              <a:t>   Financial: S&amp;P 500, VIX/OVX, gold, copper, DXY, 10Y Treasury</a:t>
-            </a:r>
-          </a:p>
-          <a:p>
-            <a:pPr>
-              <a:spcAft>
-                <a:spcPts val="400"/>
-              </a:spcAft>
-              <a:defRPr sz="1800"/>
-            </a:pPr>
-            <a:r>
-              <a:t>   Macro: industrial production, global econ activity, GPR index</a:t>
-            </a:r>
-          </a:p>
-          <a:p>
-            <a:pPr>
-              <a:spcAft>
-                <a:spcPts val="400"/>
-              </a:spcAft>
-              <a:defRPr sz="1800"/>
-            </a:pPr>
-          </a:p>
-          <a:p>
-            <a:pPr>
-              <a:spcAft>
-                <a:spcPts val="400"/>
-              </a:spcAft>
-              <a:defRPr sz="1800"/>
-            </a:pPr>
-            <a:r>
-              <a:t>[INSERT: Correlation heatmap from notebook]</a:t>
+              <a:t>Mixed lag structure:</a:t>
+            </a:r>
+          </a:p>
+          <a:p>
+            <a:pPr>
+              <a:spcAft>
+                <a:spcPts val="400"/>
+              </a:spcAft>
+              <a:defRPr sz="1800"/>
+            </a:pPr>
+            <a:r>
+              <a:t>   Contemporaneous: heating oil, nat gas (same supply chain — expected)</a:t>
+            </a:r>
+          </a:p>
+          <a:p>
+            <a:pPr>
+              <a:spcAft>
+                <a:spcPts val="400"/>
+              </a:spcAft>
+              <a:defRPr sz="1800"/>
+            </a:pPr>
+            <a:r>
+              <a:t>   Lagged (t-1): financials, macro, geopolitical (the real test)</a:t>
+            </a:r>
+          </a:p>
+          <a:p>
+            <a:pPr>
+              <a:spcAft>
+                <a:spcPts val="400"/>
+              </a:spcAft>
+              <a:defRPr sz="1800"/>
+            </a:pPr>
+          </a:p>
+          <a:p>
+            <a:pPr>
+              <a:spcAft>
+                <a:spcPts val="400"/>
+              </a:spcAft>
+              <a:defRPr sz="1800"/>
+            </a:pPr>
+            <a:r>
+              <a:t>[INSERT: Correlation heatmap + WTI returns with event markers]</a:t>
             </a:r>
           </a:p>
         </p:txBody>
@@ -3361,7 +3419,7 @@
                   <a:srgbClr val="2C3E50"/>
                 </a:solidFill>
               </a:rPr>
-              <a:t>OLS Results — Lagged Predictors</a:t>
+              <a:t>OLS Results — Mixed Lag Structure</a:t>
             </a:r>
           </a:p>
         </p:txBody>
@@ -3388,122 +3446,111 @@
               <a:defRPr sz="1800"/>
             </a:pPr>
             <a:r>
-              <a:t>Monthly:  Adj. R² = 0.053  (2 significant lagged predictors)</a:t>
-            </a:r>
-          </a:p>
-          <a:p>
-            <a:pPr>
-              <a:spcAft>
-                <a:spcPts val="400"/>
-              </a:spcAft>
-              <a:defRPr sz="1800"/>
-            </a:pPr>
-            <a:r>
-              <a:t>   → 10Y Treasury yield change (p = 0.004 under HAC)</a:t>
-            </a:r>
-          </a:p>
-          <a:p>
-            <a:pPr>
-              <a:spcAft>
-                <a:spcPts val="400"/>
-              </a:spcAft>
-              <a:defRPr sz="1800"/>
-            </a:pPr>
-            <a:r>
-              <a:t>   → Industrial production (p = 0.28 under HAC — marginal)</a:t>
-            </a:r>
-          </a:p>
-          <a:p>
-            <a:pPr>
-              <a:spcAft>
-                <a:spcPts val="400"/>
-              </a:spcAft>
-              <a:defRPr sz="1800"/>
-            </a:pPr>
-          </a:p>
-          <a:p>
-            <a:pPr>
-              <a:spcAft>
-                <a:spcPts val="400"/>
-              </a:spcAft>
-              <a:defRPr sz="1800"/>
-            </a:pPr>
-            <a:r>
-              <a:t>Weekly:   Adj. R² = 0.018  (5 significant lagged predictors)</a:t>
-            </a:r>
-          </a:p>
-          <a:p>
-            <a:pPr>
-              <a:spcAft>
-                <a:spcPts val="400"/>
-              </a:spcAft>
-              <a:defRPr sz="1800"/>
-            </a:pPr>
-            <a:r>
-              <a:t>   → 10Y Treasury, refinery utilization, crude stocks,</a:t>
-            </a:r>
-          </a:p>
-          <a:p>
-            <a:pPr>
-              <a:spcAft>
-                <a:spcPts val="400"/>
-              </a:spcAft>
-              <a:defRPr sz="1800"/>
-            </a:pPr>
-            <a:r>
-              <a:t>     copper, 10Y Treasury diff</a:t>
-            </a:r>
-          </a:p>
-          <a:p>
-            <a:pPr>
-              <a:spcAft>
-                <a:spcPts val="400"/>
-              </a:spcAft>
-              <a:defRPr sz="1800"/>
-            </a:pPr>
-          </a:p>
-          <a:p>
-            <a:pPr>
-              <a:spcAft>
-                <a:spcPts val="400"/>
-              </a:spcAft>
-              <a:defRPr sz="1800"/>
-            </a:pPr>
-            <a:r>
-              <a:t>Low R² is the RIGHT answer with lagged predictors:</a:t>
-            </a:r>
-          </a:p>
-          <a:p>
-            <a:pPr>
-              <a:spcAft>
-                <a:spcPts val="400"/>
-              </a:spcAft>
-              <a:defRPr sz="1800"/>
-            </a:pPr>
-            <a:r>
-              <a:t>   WTI returns are hard to predict from last period's data</a:t>
-            </a:r>
-          </a:p>
-          <a:p>
-            <a:pPr>
-              <a:spcAft>
-                <a:spcPts val="400"/>
-              </a:spcAft>
-              <a:defRPr sz="1800"/>
-            </a:pPr>
-            <a:r>
-              <a:t>   → consistent with market efficiency</a:t>
-            </a:r>
-          </a:p>
-          <a:p>
-            <a:pPr>
-              <a:spcAft>
-                <a:spcPts val="400"/>
-              </a:spcAft>
-              <a:defRPr sz="1800"/>
-            </a:pPr>
-            <a:r>
-              <a:t>   → BUT: volatility is predictable (see GARCH results)</a:t>
+              <a:t>Monthly:  Adj. R² = 0.7435  (74.4%)</a:t>
+            </a:r>
+          </a:p>
+          <a:p>
+            <a:pPr>
+              <a:spcAft>
+                <a:spcPts val="400"/>
+              </a:spcAft>
+              <a:defRPr sz="1800"/>
+            </a:pPr>
+            <a:r>
+              <a:t>   Energy (contemp., expected): heatoil_chg_pct</a:t>
+            </a:r>
+          </a:p>
+          <a:p>
+            <a:pPr>
+              <a:spcAft>
+                <a:spcPts val="400"/>
+              </a:spcAft>
+              <a:defRPr sz="1800"/>
+            </a:pPr>
+            <a:r>
+              <a:t>   Predictive (lagged): spr_inv_chg, refin_util_rate, crude_stk_excl_spr, indpro</a:t>
+            </a:r>
+          </a:p>
+          <a:p>
+            <a:pPr>
+              <a:spcAft>
+                <a:spcPts val="400"/>
+              </a:spcAft>
+              <a:defRPr sz="1800"/>
+            </a:pPr>
+          </a:p>
+          <a:p>
+            <a:pPr>
+              <a:spcAft>
+                <a:spcPts val="400"/>
+              </a:spcAft>
+              <a:defRPr sz="1800"/>
+            </a:pPr>
+            <a:r>
+              <a:t>Weekly:   Adj. R² = 0.6488  (64.9%)</a:t>
+            </a:r>
+          </a:p>
+          <a:p>
+            <a:pPr>
+              <a:spcAft>
+                <a:spcPts val="400"/>
+              </a:spcAft>
+              <a:defRPr sz="1800"/>
+            </a:pPr>
+            <a:r>
+              <a:t>   Energy (contemp.): heatoil_chg_pct</a:t>
+            </a:r>
+          </a:p>
+          <a:p>
+            <a:pPr>
+              <a:spcAft>
+                <a:spcPts val="400"/>
+              </a:spcAft>
+              <a:defRPr sz="1800"/>
+            </a:pPr>
+            <a:r>
+              <a:t>   Predictive (lagged): copper_chg_pct, brent_chg_pct, ovx_chg_pct, rbob_chg_pct...</a:t>
+            </a:r>
+          </a:p>
+          <a:p>
+            <a:pPr>
+              <a:spcAft>
+                <a:spcPts val="400"/>
+              </a:spcAft>
+              <a:defRPr sz="1800"/>
+            </a:pPr>
+          </a:p>
+          <a:p>
+            <a:pPr>
+              <a:spcAft>
+                <a:spcPts val="400"/>
+              </a:spcAft>
+              <a:defRPr sz="1800"/>
+            </a:pPr>
+            <a:r>
+              <a:t>Most R² comes from energy co-movement (expected, uninteresting)</a:t>
+            </a:r>
+          </a:p>
+          <a:p>
+            <a:pPr>
+              <a:spcAft>
+                <a:spcPts val="400"/>
+              </a:spcAft>
+              <a:defRPr sz="1800"/>
+            </a:pPr>
+            <a:r>
+              <a:t>The lagged predictors are the real contribution:</a:t>
+            </a:r>
+          </a:p>
+          <a:p>
+            <a:pPr>
+              <a:spcAft>
+                <a:spcPts val="400"/>
+              </a:spcAft>
+              <a:defRPr sz="1800"/>
+            </a:pPr>
+            <a:r>
+              <a:t>   SPR inventory, crude stocks, industrial production, refinery util</a:t>
             </a:r>
           </a:p>
         </p:txBody>
@@ -3574,144 +3621,111 @@
               <a:defRPr sz="1800"/>
             </a:pPr>
             <a:r>
-              <a:t>#   Assumption              Test              Monthly      Weekly</a:t>
-            </a:r>
-          </a:p>
-          <a:p>
-            <a:pPr>
-              <a:spcAft>
-                <a:spcPts val="400"/>
-              </a:spcAft>
-              <a:defRPr sz="1800"/>
-            </a:pPr>
-            <a:r>
-              <a:t>─────────────────────────────────────────────────────────────</a:t>
-            </a:r>
-          </a:p>
-          <a:p>
-            <a:pPr>
-              <a:spcAft>
-                <a:spcPts val="400"/>
-              </a:spcAft>
-              <a:defRPr sz="1800"/>
-            </a:pPr>
-            <a:r>
-              <a:t>1   E(εₜ) = 0               Constant          ✓ OK         ✓ OK</a:t>
-            </a:r>
-          </a:p>
-          <a:p>
-            <a:pPr>
-              <a:spcAft>
-                <a:spcPts val="400"/>
-              </a:spcAft>
-              <a:defRPr sz="1800"/>
-            </a:pPr>
-            <a:r>
-              <a:t>2   Var(εₜ) = σ²            Breusch-Pagan     ✗ p=0.000    ✗ p=0.000</a:t>
-            </a:r>
-          </a:p>
-          <a:p>
-            <a:pPr>
-              <a:spcAft>
-                <a:spcPts val="400"/>
-              </a:spcAft>
-              <a:defRPr sz="1800"/>
-            </a:pPr>
-            <a:r>
-              <a:t>3   Cov(εᵢ,εⱼ) = 0         DW / BG           ✓ OK         ✓ OK</a:t>
-            </a:r>
-          </a:p>
-          <a:p>
-            <a:pPr>
-              <a:spcAft>
-                <a:spcPts val="400"/>
-              </a:spcAft>
-              <a:defRPr sz="1800"/>
-            </a:pPr>
-            <a:r>
-              <a:t>4   Cov(xₜ,εₜ) = 0         Lagged X          ✓ by design  ✓ by design</a:t>
-            </a:r>
-          </a:p>
-          <a:p>
-            <a:pPr>
-              <a:spcAft>
-                <a:spcPts val="400"/>
-              </a:spcAft>
-              <a:defRPr sz="1800"/>
-            </a:pPr>
-            <a:r>
-              <a:t>5   εₜ ~ N(0,σ²)           Jarque-Bera       ✗ JB=516     ✗ JB=927</a:t>
-            </a:r>
-          </a:p>
-          <a:p>
-            <a:pPr>
-              <a:spcAft>
-                <a:spcPts val="400"/>
-              </a:spcAft>
-              <a:defRPr sz="1800"/>
-            </a:pPr>
-          </a:p>
-          <a:p>
-            <a:pPr>
-              <a:spcAft>
-                <a:spcPts val="400"/>
-              </a:spcAft>
-              <a:defRPr sz="1800"/>
-            </a:pPr>
-            <a:r>
-              <a:t>Also: ARCH-LM → p = 0.000 at both frequencies</a:t>
-            </a:r>
-          </a:p>
-          <a:p>
-            <a:pPr>
-              <a:spcAft>
-                <a:spcPts val="400"/>
-              </a:spcAft>
-              <a:defRPr sz="1800"/>
-            </a:pPr>
-          </a:p>
-          <a:p>
-            <a:pPr>
-              <a:spcAft>
-                <a:spcPts val="400"/>
-              </a:spcAft>
-              <a:defRPr sz="1800"/>
-            </a:pPr>
-            <a:r>
-              <a:t>Fixes applied:</a:t>
-            </a:r>
-          </a:p>
-          <a:p>
-            <a:pPr>
-              <a:spcAft>
-                <a:spcPts val="400"/>
-              </a:spcAft>
-              <a:defRPr sz="1800"/>
-            </a:pPr>
-            <a:r>
-              <a:t>   → Newey-West (HAC) standard errors for Assumption 2</a:t>
-            </a:r>
-          </a:p>
-          <a:p>
-            <a:pPr>
-              <a:spcAft>
-                <a:spcPts val="400"/>
-              </a:spcAft>
-              <a:defRPr sz="1800"/>
-            </a:pPr>
-            <a:r>
-              <a:t>   → GARCH + Student-t for Assumptions 2 &amp; 5 + ARCH effects</a:t>
-            </a:r>
-          </a:p>
-          <a:p>
-            <a:pPr>
-              <a:spcAft>
-                <a:spcPts val="400"/>
-              </a:spcAft>
-              <a:defRPr sz="1800"/>
-            </a:pPr>
-            <a:r>
-              <a:t>   → Lagged predictors satisfy Assumption 4 by construction</a:t>
+              <a:t>#   Assumption              Test              Monthly        Weekly</a:t>
+            </a:r>
+          </a:p>
+          <a:p>
+            <a:pPr>
+              <a:spcAft>
+                <a:spcPts val="400"/>
+              </a:spcAft>
+              <a:defRPr sz="1800"/>
+            </a:pPr>
+            <a:r>
+              <a:t>──────────────────────────────────────────────────────────────────</a:t>
+            </a:r>
+          </a:p>
+          <a:p>
+            <a:pPr>
+              <a:spcAft>
+                <a:spcPts val="400"/>
+              </a:spcAft>
+              <a:defRPr sz="1800"/>
+            </a:pPr>
+            <a:r>
+              <a:t>1   E(εₜ) = 0               Constant          OK             OK</a:t>
+            </a:r>
+          </a:p>
+          <a:p>
+            <a:pPr>
+              <a:spcAft>
+                <a:spcPts val="400"/>
+              </a:spcAft>
+              <a:defRPr sz="1800"/>
+            </a:pPr>
+            <a:r>
+              <a:t>2   Var(εₜ) = σ²            Breusch-Pagan     p=0.0000       p=0.0010</a:t>
+            </a:r>
+          </a:p>
+          <a:p>
+            <a:pPr>
+              <a:spcAft>
+                <a:spcPts val="400"/>
+              </a:spcAft>
+              <a:defRPr sz="1800"/>
+            </a:pPr>
+            <a:r>
+              <a:t>3   Cov(εᵢ,εⱼ) = 0         DW / BG           DW=1.882       DW=2.112</a:t>
+            </a:r>
+          </a:p>
+          <a:p>
+            <a:pPr>
+              <a:spcAft>
+                <a:spcPts val="400"/>
+              </a:spcAft>
+              <a:defRPr sz="1800"/>
+            </a:pPr>
+            <a:r>
+              <a:t>4   Cov(xₜ,εₜ) = 0         Lagged X          OK by design   OK by design</a:t>
+            </a:r>
+          </a:p>
+          <a:p>
+            <a:pPr>
+              <a:spcAft>
+                <a:spcPts val="400"/>
+              </a:spcAft>
+              <a:defRPr sz="1800"/>
+            </a:pPr>
+            <a:r>
+              <a:t>5   εₜ ~ N(0,σ²)           Jarque-Bera       JB=1431.5      VIOLATED</a:t>
+            </a:r>
+          </a:p>
+          <a:p>
+            <a:pPr>
+              <a:spcAft>
+                <a:spcPts val="400"/>
+              </a:spcAft>
+              <a:defRPr sz="1800"/>
+            </a:pPr>
+          </a:p>
+          <a:p>
+            <a:pPr>
+              <a:spcAft>
+                <a:spcPts val="400"/>
+              </a:spcAft>
+              <a:defRPr sz="1800"/>
+            </a:pPr>
+            <a:r>
+              <a:t>ARCH-LM: Monthly p=0.0000, Weekly p=0.0000</a:t>
+            </a:r>
+          </a:p>
+          <a:p>
+            <a:pPr>
+              <a:spcAft>
+                <a:spcPts val="400"/>
+              </a:spcAft>
+              <a:defRPr sz="1800"/>
+            </a:pPr>
+          </a:p>
+          <a:p>
+            <a:pPr>
+              <a:spcAft>
+                <a:spcPts val="400"/>
+              </a:spcAft>
+              <a:defRPr sz="1800"/>
+            </a:pPr>
+            <a:r>
+              <a:t>Fixes: HAC std errors + GARCH with Student-t</a:t>
             </a:r>
           </a:p>
         </p:txBody>
@@ -3755,7 +3769,7 @@
                   <a:srgbClr val="2C3E50"/>
                 </a:solidFill>
               </a:rPr>
-              <a:t>Residual Diagnostics</a:t>
+              <a:t>GARCH — Volatility is Predictable</a:t>
             </a:r>
           </a:p>
         </p:txBody>
@@ -3782,100 +3796,141 @@
               <a:defRPr sz="1800"/>
             </a:pPr>
             <a:r>
-              <a:t>[INSERT: 4-panel residual plot from notebook]</a:t>
-            </a:r>
-          </a:p>
-          <a:p>
-            <a:pPr>
-              <a:spcAft>
-                <a:spcPts val="400"/>
-              </a:spcAft>
-              <a:defRPr sz="1800"/>
-            </a:pPr>
-          </a:p>
-          <a:p>
-            <a:pPr>
-              <a:spcAft>
-                <a:spcPts val="400"/>
-              </a:spcAft>
-              <a:defRPr sz="1800"/>
-            </a:pPr>
-            <a:r>
-              <a:t>   Top-left: Residuals over time — no obvious pattern ✓</a:t>
-            </a:r>
-          </a:p>
-          <a:p>
-            <a:pPr>
-              <a:spcAft>
-                <a:spcPts val="400"/>
-              </a:spcAft>
-              <a:defRPr sz="1800"/>
-            </a:pPr>
-            <a:r>
-              <a:t>   Top-right: Histogram — fat tails visible vs. normal overlay</a:t>
-            </a:r>
-          </a:p>
-          <a:p>
-            <a:pPr>
-              <a:spcAft>
-                <a:spcPts val="400"/>
-              </a:spcAft>
-              <a:defRPr sz="1800"/>
-            </a:pPr>
-            <a:r>
-              <a:t>   Bottom-left: ACF of residuals — minimal autocorrelation ✓</a:t>
-            </a:r>
-          </a:p>
-          <a:p>
-            <a:pPr>
-              <a:spcAft>
-                <a:spcPts val="400"/>
-              </a:spcAft>
-              <a:defRPr sz="1800"/>
-            </a:pPr>
-            <a:r>
-              <a:t>   Bottom-right: Squared residuals — volatility clustering clear</a:t>
-            </a:r>
-          </a:p>
-          <a:p>
-            <a:pPr>
-              <a:spcAft>
-                <a:spcPts val="400"/>
-              </a:spcAft>
-              <a:defRPr sz="1800"/>
-            </a:pPr>
-          </a:p>
-          <a:p>
-            <a:pPr>
-              <a:spcAft>
-                <a:spcPts val="400"/>
-              </a:spcAft>
-              <a:defRPr sz="1800"/>
-            </a:pPr>
-            <a:r>
-              <a:t>Key takeaway: residuals are heteroskedastic and fat-tailed</a:t>
-            </a:r>
-          </a:p>
-          <a:p>
-            <a:pPr>
-              <a:spcAft>
-                <a:spcPts val="400"/>
-              </a:spcAft>
-              <a:defRPr sz="1800"/>
-            </a:pPr>
-            <a:r>
-              <a:t>   → OLS standard errors unreliable</a:t>
-            </a:r>
-          </a:p>
-          <a:p>
-            <a:pPr>
-              <a:spcAft>
-                <a:spcPts val="400"/>
-              </a:spcAft>
-              <a:defRPr sz="1800"/>
-            </a:pPr>
-            <a:r>
-              <a:t>   → Need HAC and GARCH</a:t>
+              <a:t>Monthly: GJR-GARCH(1,1) selected (AIC = 2404.1)</a:t>
+            </a:r>
+          </a:p>
+          <a:p>
+            <a:pPr>
+              <a:spcAft>
+                <a:spcPts val="400"/>
+              </a:spcAft>
+              <a:defRPr sz="1800"/>
+            </a:pPr>
+            <a:r>
+              <a:t>   Persistence = 0.8109 — shocks are persistent</a:t>
+            </a:r>
+          </a:p>
+          <a:p>
+            <a:pPr>
+              <a:spcAft>
+                <a:spcPts val="400"/>
+              </a:spcAft>
+              <a:defRPr sz="1800"/>
+            </a:pPr>
+            <a:r>
+              <a:t>   Student-t df ≈ 4.2 — fat tails confirmed</a:t>
+            </a:r>
+          </a:p>
+          <a:p>
+            <a:pPr>
+              <a:spcAft>
+                <a:spcPts val="400"/>
+              </a:spcAft>
+              <a:defRPr sz="1800"/>
+            </a:pPr>
+            <a:r>
+              <a:t>   GJR asymmetry: negative shocks → MORE volatility</a:t>
+            </a:r>
+          </a:p>
+          <a:p>
+            <a:pPr>
+              <a:spcAft>
+                <a:spcPts val="400"/>
+              </a:spcAft>
+              <a:defRPr sz="1800"/>
+            </a:pPr>
+          </a:p>
+          <a:p>
+            <a:pPr>
+              <a:spcAft>
+                <a:spcPts val="400"/>
+              </a:spcAft>
+              <a:defRPr sz="1800"/>
+            </a:pPr>
+            <a:r>
+              <a:t>Weekly: GARCH(1,1) selected</a:t>
+            </a:r>
+          </a:p>
+          <a:p>
+            <a:pPr>
+              <a:spcAft>
+                <a:spcPts val="400"/>
+              </a:spcAft>
+              <a:defRPr sz="1800"/>
+            </a:pPr>
+            <a:r>
+              <a:t>   Persistence = 0.9281</a:t>
+            </a:r>
+          </a:p>
+          <a:p>
+            <a:pPr>
+              <a:spcAft>
+                <a:spcPts val="400"/>
+              </a:spcAft>
+              <a:defRPr sz="1800"/>
+            </a:pPr>
+            <a:r>
+              <a:t>   Passes post-ARCH-LM (p=0.2272) — adequate fit</a:t>
+            </a:r>
+          </a:p>
+          <a:p>
+            <a:pPr>
+              <a:spcAft>
+                <a:spcPts val="400"/>
+              </a:spcAft>
+              <a:defRPr sz="1800"/>
+            </a:pPr>
+          </a:p>
+          <a:p>
+            <a:pPr>
+              <a:spcAft>
+                <a:spcPts val="400"/>
+              </a:spcAft>
+              <a:defRPr sz="1800"/>
+            </a:pPr>
+            <a:r>
+              <a:t>This supports the hypothesis:</a:t>
+            </a:r>
+          </a:p>
+          <a:p>
+            <a:pPr>
+              <a:spcAft>
+                <a:spcPts val="400"/>
+              </a:spcAft>
+              <a:defRPr sz="1800"/>
+            </a:pPr>
+            <a:r>
+              <a:t>   Geopolitical events generate volatility spikes that persist</a:t>
+            </a:r>
+          </a:p>
+          <a:p>
+            <a:pPr>
+              <a:spcAft>
+                <a:spcPts val="400"/>
+              </a:spcAft>
+              <a:defRPr sz="1800"/>
+            </a:pPr>
+            <a:r>
+              <a:t>   → the GARCH variance equation captures this transmission channel</a:t>
+            </a:r>
+          </a:p>
+          <a:p>
+            <a:pPr>
+              <a:spcAft>
+                <a:spcPts val="400"/>
+              </a:spcAft>
+              <a:defRPr sz="1800"/>
+            </a:pPr>
+          </a:p>
+          <a:p>
+            <a:pPr>
+              <a:spcAft>
+                <a:spcPts val="400"/>
+              </a:spcAft>
+              <a:defRPr sz="1800"/>
+            </a:pPr>
+            <a:r>
+              <a:t>[INSERT: Conditional volatility plot with Desert Storm, 9/11, 2008, COVID, Ukraine]</a:t>
             </a:r>
           </a:p>
         </p:txBody>
@@ -3919,7 +3974,7 @@
                   <a:srgbClr val="2C3E50"/>
                 </a:solidFill>
               </a:rPr>
-              <a:t>GARCH Volatility Model</a:t>
+              <a:t>Structural Break Analysis</a:t>
             </a:r>
           </a:p>
         </p:txBody>
@@ -3946,138 +4001,122 @@
               <a:defRPr sz="1800"/>
             </a:pPr>
             <a:r>
-              <a:t>Compared: GARCH(1,1) vs EGARCH(1,1) vs GJR-GARCH(1,1)</a:t>
-            </a:r>
-          </a:p>
-          <a:p>
-            <a:pPr>
-              <a:spcAft>
-                <a:spcPts val="400"/>
-              </a:spcAft>
-              <a:defRPr sz="1800"/>
-            </a:pPr>
-          </a:p>
-          <a:p>
-            <a:pPr>
-              <a:spcAft>
-                <a:spcPts val="400"/>
-              </a:spcAft>
-              <a:defRPr sz="1800"/>
-            </a:pPr>
-            <a:r>
-              <a:t>Monthly → GJR-GARCH(1,1) selected (lowest AIC = 3013)</a:t>
-            </a:r>
-          </a:p>
-          <a:p>
-            <a:pPr>
-              <a:spcAft>
-                <a:spcPts val="400"/>
-              </a:spcAft>
-              <a:defRPr sz="1800"/>
-            </a:pPr>
-            <a:r>
-              <a:t>   Persistence = 0.876 — volatility shocks are persistent</a:t>
-            </a:r>
-          </a:p>
-          <a:p>
-            <a:pPr>
-              <a:spcAft>
-                <a:spcPts val="400"/>
-              </a:spcAft>
-              <a:defRPr sz="1800"/>
-            </a:pPr>
-            <a:r>
-              <a:t>   Student-t df ≈ 11</a:t>
-            </a:r>
-          </a:p>
-          <a:p>
-            <a:pPr>
-              <a:spcAft>
-                <a:spcPts val="400"/>
-              </a:spcAft>
-              <a:defRPr sz="1800"/>
-            </a:pPr>
-          </a:p>
-          <a:p>
-            <a:pPr>
-              <a:spcAft>
-                <a:spcPts val="400"/>
-              </a:spcAft>
-              <a:defRPr sz="1800"/>
-            </a:pPr>
-            <a:r>
-              <a:t>Weekly → GARCH(1,1) by AIC, but EGARCH passes ARCH-LM (p=0.65)</a:t>
-            </a:r>
-          </a:p>
-          <a:p>
-            <a:pPr>
-              <a:spcAft>
-                <a:spcPts val="400"/>
-              </a:spcAft>
-              <a:defRPr sz="1800"/>
-            </a:pPr>
-            <a:r>
-              <a:t>   Persistence = 0.644 — lower than monthly</a:t>
-            </a:r>
-          </a:p>
-          <a:p>
-            <a:pPr>
-              <a:spcAft>
-                <a:spcPts val="400"/>
-              </a:spcAft>
-              <a:defRPr sz="1800"/>
-            </a:pPr>
-          </a:p>
-          <a:p>
-            <a:pPr>
-              <a:spcAft>
-                <a:spcPts val="400"/>
-              </a:spcAft>
-              <a:defRPr sz="1800"/>
-            </a:pPr>
-            <a:r>
-              <a:t>GARCH reveals: even though RETURNS are unpredictable,</a:t>
-            </a:r>
-          </a:p>
-          <a:p>
-            <a:pPr>
-              <a:spcAft>
-                <a:spcPts val="400"/>
-              </a:spcAft>
-              <a:defRPr sz="1800"/>
-            </a:pPr>
-            <a:r>
-              <a:t>VOLATILITY is predictable and persistent</a:t>
-            </a:r>
-          </a:p>
-          <a:p>
-            <a:pPr>
-              <a:spcAft>
-                <a:spcPts val="400"/>
-              </a:spcAft>
-              <a:defRPr sz="1800"/>
-            </a:pPr>
-            <a:r>
-              <a:t>→ Practical value for risk management and hedging</a:t>
-            </a:r>
-          </a:p>
-          <a:p>
-            <a:pPr>
-              <a:spcAft>
-                <a:spcPts val="400"/>
-              </a:spcAft>
-              <a:defRPr sz="1800"/>
-            </a:pPr>
-          </a:p>
-          <a:p>
-            <a:pPr>
-              <a:spcAft>
-                <a:spcPts val="400"/>
-              </a:spcAft>
-              <a:defRPr sz="1800"/>
-            </a:pPr>
-            <a:r>
-              <a:t>[INSERT: Conditional volatility plot — note 2008, COVID spikes]</a:t>
+              <a:t>Sub-period regressions show parameter instability:</a:t>
+            </a:r>
+          </a:p>
+          <a:p>
+            <a:pPr>
+              <a:spcAft>
+                <a:spcPts val="400"/>
+              </a:spcAft>
+              <a:defRPr sz="1800"/>
+            </a:pPr>
+          </a:p>
+          <a:p>
+            <a:pPr>
+              <a:spcAft>
+                <a:spcPts val="400"/>
+              </a:spcAft>
+              <a:defRPr sz="1800"/>
+            </a:pPr>
+            <a:r>
+              <a:t>   Pre-9/11 (1991-2001)          R²=0.6964  → heatoil, indpro</a:t>
+            </a:r>
+          </a:p>
+          <a:p>
+            <a:pPr>
+              <a:spcAft>
+                <a:spcPts val="400"/>
+              </a:spcAft>
+              <a:defRPr sz="1800"/>
+            </a:pPr>
+            <a:r>
+              <a:t>   Post-9/11 to Crisis           R²=0.8313  → heatoil</a:t>
+            </a:r>
+          </a:p>
+          <a:p>
+            <a:pPr>
+              <a:spcAft>
+                <a:spcPts val="400"/>
+              </a:spcAft>
+              <a:defRPr sz="1800"/>
+            </a:pPr>
+            <a:r>
+              <a:t>   Financial Crisis (2008-10)    R²=0.8756  → heatoil, spr_inv_chg</a:t>
+            </a:r>
+          </a:p>
+          <a:p>
+            <a:pPr>
+              <a:spcAft>
+                <a:spcPts val="400"/>
+              </a:spcAft>
+              <a:defRPr sz="1800"/>
+            </a:pPr>
+            <a:r>
+              <a:t>   Recovery+Shale (2011-19)      R²=0.7635  → heatoil, indpro</a:t>
+            </a:r>
+          </a:p>
+          <a:p>
+            <a:pPr>
+              <a:spcAft>
+                <a:spcPts val="400"/>
+              </a:spcAft>
+              <a:defRPr sz="1800"/>
+            </a:pPr>
+            <a:r>
+              <a:t>   COVID+Ukraine (2020-25)       R²=0.7949  → heatoil, refin_util_rate, crude_stk_excl_spr, indpro</a:t>
+            </a:r>
+          </a:p>
+          <a:p>
+            <a:pPr>
+              <a:spcAft>
+                <a:spcPts val="400"/>
+              </a:spcAft>
+              <a:defRPr sz="1800"/>
+            </a:pPr>
+          </a:p>
+          <a:p>
+            <a:pPr>
+              <a:spcAft>
+                <a:spcPts val="400"/>
+              </a:spcAft>
+              <a:defRPr sz="1800"/>
+            </a:pPr>
+            <a:r>
+              <a:t>Heating oil always significant (expected co-movement)</a:t>
+            </a:r>
+          </a:p>
+          <a:p>
+            <a:pPr>
+              <a:spcAft>
+                <a:spcPts val="400"/>
+              </a:spcAft>
+              <a:defRPr sz="1800"/>
+            </a:pPr>
+            <a:r>
+              <a:t>Lagged predictors shift: INDPRO in calm periods, SPR during crises,</a:t>
+            </a:r>
+          </a:p>
+          <a:p>
+            <a:pPr>
+              <a:spcAft>
+                <a:spcPts val="400"/>
+              </a:spcAft>
+              <a:defRPr sz="1800"/>
+            </a:pPr>
+            <a:r>
+              <a:t>   crude stocks + refinery util in COVID/Ukraine era</a:t>
+            </a:r>
+          </a:p>
+          <a:p>
+            <a:pPr>
+              <a:spcAft>
+                <a:spcPts val="400"/>
+              </a:spcAft>
+              <a:defRPr sz="1800"/>
+            </a:pPr>
+            <a:r>
+              <a:t>→ Different regimes activate different channels</a:t>
             </a:r>
           </a:p>
         </p:txBody>
@@ -4121,7 +4160,7 @@
                   <a:srgbClr val="2C3E50"/>
                 </a:solidFill>
               </a:rPr>
-              <a:t>Monthly vs. Weekly Comparison</a:t>
+              <a:t>Out-of-Sample Test</a:t>
             </a:r>
           </a:p>
         </p:txBody>
@@ -4148,136 +4187,108 @@
               <a:defRPr sz="1800"/>
             </a:pPr>
             <a:r>
-              <a:t>Metric                   Monthly         Weekly</a:t>
-            </a:r>
-          </a:p>
-          <a:p>
-            <a:pPr>
-              <a:spcAft>
-                <a:spcPts val="400"/>
-              </a:spcAft>
-              <a:defRPr sz="1800"/>
-            </a:pPr>
-            <a:r>
-              <a:t>──────────────────────────────────────────────────</a:t>
-            </a:r>
-          </a:p>
-          <a:p>
-            <a:pPr>
-              <a:spcAft>
-                <a:spcPts val="400"/>
-              </a:spcAft>
-              <a:defRPr sz="1800"/>
-            </a:pPr>
-            <a:r>
-              <a:t>Observations             419              972</a:t>
-            </a:r>
-          </a:p>
-          <a:p>
-            <a:pPr>
-              <a:spcAft>
-                <a:spcPts val="400"/>
-              </a:spcAft>
-              <a:defRPr sz="1800"/>
-            </a:pPr>
-            <a:r>
-              <a:t>OLS Adj. R² (lagged)     5.3%             1.7%</a:t>
-            </a:r>
-          </a:p>
-          <a:p>
-            <a:pPr>
-              <a:spcAft>
-                <a:spcPts val="400"/>
-              </a:spcAft>
-              <a:defRPr sz="1800"/>
-            </a:pPr>
-            <a:r>
-              <a:t>ARCH-LM (OLS)            p = 0.000        p = 0.000</a:t>
-            </a:r>
-          </a:p>
-          <a:p>
-            <a:pPr>
-              <a:spcAft>
-                <a:spcPts val="400"/>
-              </a:spcAft>
-              <a:defRPr sz="1800"/>
-            </a:pPr>
-            <a:r>
-              <a:t>GARCH selected           GJR-GARCH        GARCH(1,1)</a:t>
-            </a:r>
-          </a:p>
-          <a:p>
-            <a:pPr>
-              <a:spcAft>
-                <a:spcPts val="400"/>
-              </a:spcAft>
-              <a:defRPr sz="1800"/>
-            </a:pPr>
-            <a:r>
-              <a:t>Vol. persistence         0.876            0.644</a:t>
-            </a:r>
-          </a:p>
-          <a:p>
-            <a:pPr>
-              <a:spcAft>
-                <a:spcPts val="400"/>
-              </a:spcAft>
-              <a:defRPr sz="1800"/>
-            </a:pPr>
-          </a:p>
-          <a:p>
-            <a:pPr>
-              <a:spcAft>
-                <a:spcPts val="400"/>
-              </a:spcAft>
-              <a:defRPr sz="1800"/>
-            </a:pPr>
-            <a:r>
-              <a:t>Key points:</a:t>
-            </a:r>
-          </a:p>
-          <a:p>
-            <a:pPr>
-              <a:spcAft>
-                <a:spcPts val="400"/>
-              </a:spcAft>
-              <a:defRPr sz="1800"/>
-            </a:pPr>
-            <a:r>
-              <a:t>   → Both show low R² — consistent with efficient markets</a:t>
-            </a:r>
-          </a:p>
-          <a:p>
-            <a:pPr>
-              <a:spcAft>
-                <a:spcPts val="400"/>
-              </a:spcAft>
-              <a:defRPr sz="1800"/>
-            </a:pPr>
-            <a:r>
-              <a:t>   → 10Y Treasury significant at both → robust lagged signal</a:t>
-            </a:r>
-          </a:p>
-          <a:p>
-            <a:pPr>
-              <a:spcAft>
-                <a:spcPts val="400"/>
-              </a:spcAft>
-              <a:defRPr sz="1800"/>
-            </a:pPr>
-            <a:r>
-              <a:t>   → ARCH effects strong at both → volatility is predictable</a:t>
-            </a:r>
-          </a:p>
-          <a:p>
-            <a:pPr>
-              <a:spcAft>
-                <a:spcPts val="400"/>
-              </a:spcAft>
-              <a:defRPr sz="1800"/>
-            </a:pPr>
-            <a:r>
-              <a:t>   → Monthly persistence higher — shocks last longer</a:t>
+              <a:t>Train: 212 obs (1991 – Aug 2008)   Test: 208 obs (Sep 2008 – Dec 2025)</a:t>
+            </a:r>
+          </a:p>
+          <a:p>
+            <a:pPr>
+              <a:spcAft>
+                <a:spcPts val="400"/>
+              </a:spcAft>
+              <a:defRPr sz="1800"/>
+            </a:pPr>
+          </a:p>
+          <a:p>
+            <a:pPr>
+              <a:spcAft>
+                <a:spcPts val="400"/>
+              </a:spcAft>
+              <a:defRPr sz="1800"/>
+            </a:pPr>
+            <a:r>
+              <a:t>   RMSE:               0.0760</a:t>
+            </a:r>
+          </a:p>
+          <a:p>
+            <a:pPr>
+              <a:spcAft>
+                <a:spcPts val="400"/>
+              </a:spcAft>
+              <a:defRPr sz="1800"/>
+            </a:pPr>
+            <a:r>
+              <a:t>   MAE:                0.0406</a:t>
+            </a:r>
+          </a:p>
+          <a:p>
+            <a:pPr>
+              <a:spcAft>
+                <a:spcPts val="400"/>
+              </a:spcAft>
+              <a:defRPr sz="1800"/>
+            </a:pPr>
+            <a:r>
+              <a:t>   Direction accuracy: 88.0%</a:t>
+            </a:r>
+          </a:p>
+          <a:p>
+            <a:pPr>
+              <a:spcAft>
+                <a:spcPts val="400"/>
+              </a:spcAft>
+              <a:defRPr sz="1800"/>
+            </a:pPr>
+            <a:r>
+              <a:t>   Out-of-sample R²:   0.5653</a:t>
+            </a:r>
+          </a:p>
+          <a:p>
+            <a:pPr>
+              <a:spcAft>
+                <a:spcPts val="400"/>
+              </a:spcAft>
+              <a:defRPr sz="1800"/>
+            </a:pPr>
+          </a:p>
+          <a:p>
+            <a:pPr>
+              <a:spcAft>
+                <a:spcPts val="400"/>
+              </a:spcAft>
+              <a:defRPr sz="1800"/>
+            </a:pPr>
+            <a:r>
+              <a:t>Model trained on pre-crisis data generalizes to crisis + post-crisis</a:t>
+            </a:r>
+          </a:p>
+          <a:p>
+            <a:pPr>
+              <a:spcAft>
+                <a:spcPts val="400"/>
+              </a:spcAft>
+              <a:defRPr sz="1800"/>
+            </a:pPr>
+            <a:r>
+              <a:t>88% direction accuracy is genuinely strong</a:t>
+            </a:r>
+          </a:p>
+          <a:p>
+            <a:pPr>
+              <a:spcAft>
+                <a:spcPts val="400"/>
+              </a:spcAft>
+              <a:defRPr sz="1800"/>
+            </a:pPr>
+          </a:p>
+          <a:p>
+            <a:pPr>
+              <a:spcAft>
+                <a:spcPts val="400"/>
+              </a:spcAft>
+              <a:defRPr sz="1800"/>
+            </a:pPr>
+            <a:r>
+              <a:t>[INSERT: Actual vs Predicted plot]</a:t>
             </a:r>
           </a:p>
         </p:txBody>
@@ -4321,7 +4332,7 @@
                   <a:srgbClr val="2C3E50"/>
                 </a:solidFill>
               </a:rPr>
-              <a:t>Conclusion</a:t>
+              <a:t>Monthly vs. Weekly</a:t>
             </a:r>
           </a:p>
         </p:txBody>
@@ -4348,138 +4359,114 @@
               <a:defRPr sz="1800"/>
             </a:pPr>
             <a:r>
-              <a:t>Hypothesis: partially supported</a:t>
-            </a:r>
-          </a:p>
-          <a:p>
-            <a:pPr>
-              <a:spcAft>
-                <a:spcPts val="400"/>
-              </a:spcAft>
-              <a:defRPr sz="1800"/>
-            </a:pPr>
-          </a:p>
-          <a:p>
-            <a:pPr>
-              <a:spcAft>
-                <a:spcPts val="400"/>
-              </a:spcAft>
-              <a:defRPr sz="1800"/>
-            </a:pPr>
-            <a:r>
-              <a:t>Mean returns are largely unpredictable from lagged data</a:t>
-            </a:r>
-          </a:p>
-          <a:p>
-            <a:pPr>
-              <a:spcAft>
-                <a:spcPts val="400"/>
-              </a:spcAft>
-              <a:defRPr sz="1800"/>
-            </a:pPr>
-            <a:r>
-              <a:t>   → R² ≈ 5% monthly, 2% weekly</a:t>
-            </a:r>
-          </a:p>
-          <a:p>
-            <a:pPr>
-              <a:spcAft>
-                <a:spcPts val="400"/>
-              </a:spcAft>
-              <a:defRPr sz="1800"/>
-            </a:pPr>
-            <a:r>
-              <a:t>   → Consistent with semi-strong form market efficiency</a:t>
-            </a:r>
-          </a:p>
-          <a:p>
-            <a:pPr>
-              <a:spcAft>
-                <a:spcPts val="400"/>
-              </a:spcAft>
-              <a:defRPr sz="1800"/>
-            </a:pPr>
-          </a:p>
-          <a:p>
-            <a:pPr>
-              <a:spcAft>
-                <a:spcPts val="400"/>
-              </a:spcAft>
-              <a:defRPr sz="1800"/>
-            </a:pPr>
-            <a:r>
-              <a:t>But VOLATILITY is highly predictable and persistent</a:t>
-            </a:r>
-          </a:p>
-          <a:p>
-            <a:pPr>
-              <a:spcAft>
-                <a:spcPts val="400"/>
-              </a:spcAft>
-              <a:defRPr sz="1800"/>
-            </a:pPr>
-            <a:r>
-              <a:t>   → GARCH captures volatility clustering and asymmetry</a:t>
-            </a:r>
-          </a:p>
-          <a:p>
-            <a:pPr>
-              <a:spcAft>
-                <a:spcPts val="400"/>
-              </a:spcAft>
-              <a:defRPr sz="1800"/>
-            </a:pPr>
-            <a:r>
-              <a:t>   → Practical value: forecast RISK magnitude for hedging</a:t>
-            </a:r>
-          </a:p>
-          <a:p>
-            <a:pPr>
-              <a:spcAft>
-                <a:spcPts val="400"/>
-              </a:spcAft>
-              <a:defRPr sz="1800"/>
-            </a:pPr>
-          </a:p>
-          <a:p>
-            <a:pPr>
-              <a:spcAft>
-                <a:spcPts val="400"/>
-              </a:spcAft>
-              <a:defRPr sz="1800"/>
-            </a:pPr>
-            <a:r>
-              <a:t>10Y Treasury yield is the most robust lagged predictor</a:t>
-            </a:r>
-          </a:p>
-          <a:p>
-            <a:pPr>
-              <a:spcAft>
-                <a:spcPts val="400"/>
-              </a:spcAft>
-              <a:defRPr sz="1800"/>
-            </a:pPr>
-          </a:p>
-          <a:p>
-            <a:pPr>
-              <a:spcAft>
-                <a:spcPts val="400"/>
-              </a:spcAft>
-              <a:defRPr sz="1800"/>
-            </a:pPr>
-            <a:r>
-              <a:t>Future: out-of-sample volatility forecasting,</a:t>
-            </a:r>
-          </a:p>
-          <a:p>
-            <a:pPr>
-              <a:spcAft>
-                <a:spcPts val="400"/>
-              </a:spcAft>
-              <a:defRPr sz="1800"/>
-            </a:pPr>
-            <a:r>
-              <a:t>   structural breaks (2008, COVID), regime-switching GARCH</a:t>
+              <a:t>Metric                              Monthly       Weekly</a:t>
+            </a:r>
+          </a:p>
+          <a:p>
+            <a:pPr>
+              <a:spcAft>
+                <a:spcPts val="400"/>
+              </a:spcAft>
+              <a:defRPr sz="1800"/>
+            </a:pPr>
+            <a:r>
+              <a:t>──────────────────────────────────────────────────────</a:t>
+            </a:r>
+          </a:p>
+          <a:p>
+            <a:pPr>
+              <a:spcAft>
+                <a:spcPts val="400"/>
+              </a:spcAft>
+              <a:defRPr sz="1800"/>
+            </a:pPr>
+            <a:r>
+              <a:t>Observations                            419          972</a:t>
+            </a:r>
+          </a:p>
+          <a:p>
+            <a:pPr>
+              <a:spcAft>
+                <a:spcPts val="400"/>
+              </a:spcAft>
+              <a:defRPr sz="1800"/>
+            </a:pPr>
+            <a:r>
+              <a:t>OLS Adj. R²                          0.7435       0.6488</a:t>
+            </a:r>
+          </a:p>
+          <a:p>
+            <a:pPr>
+              <a:spcAft>
+                <a:spcPts val="400"/>
+              </a:spcAft>
+              <a:defRPr sz="1800"/>
+            </a:pPr>
+            <a:r>
+              <a:t>ARCH-LM p                            0.0000       0.0000</a:t>
+            </a:r>
+          </a:p>
+          <a:p>
+            <a:pPr>
+              <a:spcAft>
+                <a:spcPts val="400"/>
+              </a:spcAft>
+              <a:defRPr sz="1800"/>
+            </a:pPr>
+            <a:r>
+              <a:t>GARCH                          GJR-GARCH(1,1)   GARCH(1,1)</a:t>
+            </a:r>
+          </a:p>
+          <a:p>
+            <a:pPr>
+              <a:spcAft>
+                <a:spcPts val="400"/>
+              </a:spcAft>
+              <a:defRPr sz="1800"/>
+            </a:pPr>
+            <a:r>
+              <a:t>Persistence                          0.8109       0.9281</a:t>
+            </a:r>
+          </a:p>
+          <a:p>
+            <a:pPr>
+              <a:spcAft>
+                <a:spcPts val="400"/>
+              </a:spcAft>
+              <a:defRPr sz="1800"/>
+            </a:pPr>
+          </a:p>
+          <a:p>
+            <a:pPr>
+              <a:spcAft>
+                <a:spcPts val="400"/>
+              </a:spcAft>
+              <a:defRPr sz="1800"/>
+            </a:pPr>
+            <a:r>
+              <a:t>Heating oil significant at both → robust energy link</a:t>
+            </a:r>
+          </a:p>
+          <a:p>
+            <a:pPr>
+              <a:spcAft>
+                <a:spcPts val="400"/>
+              </a:spcAft>
+              <a:defRPr sz="1800"/>
+            </a:pPr>
+            <a:r>
+              <a:t>ARCH effects strong at both → volatility is the story</a:t>
+            </a:r>
+          </a:p>
+          <a:p>
+            <a:pPr>
+              <a:spcAft>
+                <a:spcPts val="400"/>
+              </a:spcAft>
+              <a:defRPr sz="1800"/>
+            </a:pPr>
+            <a:r>
+              <a:t>Monthly persistence lower — weekly vol shocks are stickier</a:t>
             </a:r>
           </a:p>
         </p:txBody>
@@ -4509,36 +4496,162 @@
             <a:spLocks noGrp="1"/>
           </p:cNvSpPr>
           <p:nvPr>
-            <p:ph type="ctrTitle"/>
-          </p:nvPr>
-        </p:nvSpPr>
-        <p:spPr/>
-        <p:txBody>
-          <a:bodyPr/>
-          <a:lstStyle/>
-          <a:p>
-            <a:r>
-              <a:rPr sz="3600"/>
-              <a:t>Questions?</a:t>
-            </a:r>
-          </a:p>
-        </p:txBody>
-      </p:sp>
-      <p:sp>
-        <p:nvSpPr>
-          <p:cNvPr id="3" name="Subtitle 2"/>
-          <p:cNvSpPr>
-            <a:spLocks noGrp="1"/>
-          </p:cNvSpPr>
-          <p:nvPr>
-            <p:ph type="subTitle" idx="1"/>
-          </p:nvPr>
-        </p:nvSpPr>
-        <p:spPr/>
-        <p:txBody>
-          <a:bodyPr/>
-          <a:lstStyle/>
-          <a:p/>
+            <p:ph type="title"/>
+          </p:nvPr>
+        </p:nvSpPr>
+        <p:spPr/>
+        <p:txBody>
+          <a:bodyPr/>
+          <a:lstStyle/>
+          <a:p>
+            <a:r>
+              <a:rPr sz="3200">
+                <a:solidFill>
+                  <a:srgbClr val="2C3E50"/>
+                </a:solidFill>
+              </a:rPr>
+              <a:t>Conclusion</a:t>
+            </a:r>
+          </a:p>
+        </p:txBody>
+      </p:sp>
+      <p:sp>
+        <p:nvSpPr>
+          <p:cNvPr id="3" name="Content Placeholder 2"/>
+          <p:cNvSpPr>
+            <a:spLocks noGrp="1"/>
+          </p:cNvSpPr>
+          <p:nvPr>
+            <p:ph idx="1"/>
+          </p:nvPr>
+        </p:nvSpPr>
+        <p:spPr/>
+        <p:txBody>
+          <a:bodyPr/>
+          <a:lstStyle/>
+          <a:p>
+            <a:pPr>
+              <a:spcAft>
+                <a:spcPts val="400"/>
+              </a:spcAft>
+              <a:defRPr sz="1800"/>
+            </a:pPr>
+            <a:r>
+              <a:t>Hypothesis supported: volatility is the transmission channel</a:t>
+            </a:r>
+          </a:p>
+          <a:p>
+            <a:pPr>
+              <a:spcAft>
+                <a:spcPts val="400"/>
+              </a:spcAft>
+              <a:defRPr sz="1800"/>
+            </a:pPr>
+          </a:p>
+          <a:p>
+            <a:pPr>
+              <a:spcAft>
+                <a:spcPts val="400"/>
+              </a:spcAft>
+              <a:defRPr sz="1800"/>
+            </a:pPr>
+            <a:r>
+              <a:t>1. Energy co-movement explains most R² (expected, not interesting)</a:t>
+            </a:r>
+          </a:p>
+          <a:p>
+            <a:pPr>
+              <a:spcAft>
+                <a:spcPts val="400"/>
+              </a:spcAft>
+              <a:defRPr sz="1800"/>
+            </a:pPr>
+            <a:r>
+              <a:t>2. Lagged supply fundamentals provide genuine predictive signal</a:t>
+            </a:r>
+          </a:p>
+          <a:p>
+            <a:pPr>
+              <a:spcAft>
+                <a:spcPts val="400"/>
+              </a:spcAft>
+              <a:defRPr sz="1800"/>
+            </a:pPr>
+            <a:r>
+              <a:t>3. GARCH shows volatility is persistent and forecastable</a:t>
+            </a:r>
+          </a:p>
+          <a:p>
+            <a:pPr>
+              <a:spcAft>
+                <a:spcPts val="400"/>
+              </a:spcAft>
+              <a:defRPr sz="1800"/>
+            </a:pPr>
+            <a:r>
+              <a:t>4. GJR asymmetry: negative shocks → bigger vol (supply disruption risk)</a:t>
+            </a:r>
+          </a:p>
+          <a:p>
+            <a:pPr>
+              <a:spcAft>
+                <a:spcPts val="400"/>
+              </a:spcAft>
+              <a:defRPr sz="1800"/>
+            </a:pPr>
+            <a:r>
+              <a:t>5. Out-of-sample: 88% direction accuracy across crisis periods</a:t>
+            </a:r>
+          </a:p>
+          <a:p>
+            <a:pPr>
+              <a:spcAft>
+                <a:spcPts val="400"/>
+              </a:spcAft>
+              <a:defRPr sz="1800"/>
+            </a:pPr>
+          </a:p>
+          <a:p>
+            <a:pPr>
+              <a:spcAft>
+                <a:spcPts val="400"/>
+              </a:spcAft>
+              <a:defRPr sz="1800"/>
+            </a:pPr>
+            <a:r>
+              <a:t>Practical: Use GARCH to forecast RISK, not OLS to forecast RETURNS</a:t>
+            </a:r>
+          </a:p>
+          <a:p>
+            <a:pPr>
+              <a:spcAft>
+                <a:spcPts val="400"/>
+              </a:spcAft>
+              <a:defRPr sz="1800"/>
+            </a:pPr>
+            <a:r>
+              <a:t>   The variance equation is where the actionable signal lives</a:t>
+            </a:r>
+          </a:p>
+          <a:p>
+            <a:pPr>
+              <a:spcAft>
+                <a:spcPts val="400"/>
+              </a:spcAft>
+              <a:defRPr sz="1800"/>
+            </a:pPr>
+          </a:p>
+          <a:p>
+            <a:pPr>
+              <a:spcAft>
+                <a:spcPts val="400"/>
+              </a:spcAft>
+              <a:defRPr sz="1800"/>
+            </a:pPr>
+            <a:r>
+              <a:t>Future: regime-switching GARCH, VAR, OPEC data, Chow/CUSUM tests</a:t>
+            </a:r>
+          </a:p>
         </p:txBody>
       </p:sp>
     </p:spTree>

</xml_diff>